<commit_message>
Replace "Pont" with "Connexion des enjeux" in presentation
https://claude.ai/code/session_01XeSNkxvN3AkbPmjpvnHPqf
</commit_message>
<xml_diff>
--- a/public/bible-commerciale-session1-support.pptx
+++ b/public/bible-commerciale-session1-support.pptx
@@ -6028,7 +6028,7 @@
               </a:defRPr>
             </a:pPr>
             <a:r>
-              <a:t>PONT</a:t>
+              <a:t>CONNEXION</a:t>
             </a:r>
           </a:p>
         </p:txBody>
@@ -6766,7 +6766,7 @@
               </a:defRPr>
             </a:pPr>
             <a:r>
-              <a:t>PONT</a:t>
+              <a:t>CONNEXION</a:t>
             </a:r>
           </a:p>
         </p:txBody>
@@ -7612,7 +7612,7 @@
               </a:defRPr>
             </a:pPr>
             <a:r>
-              <a:t>Les Ponts d'Enjeux</a:t>
+              <a:t>Connexion des Enjeux</a:t>
             </a:r>
           </a:p>
         </p:txBody>

</xml_diff>